<commit_message>
bench_ctb: EFC figure carries both DMs and the DM1-only comparison
ctb_efc's figure grows to five panels -- before/after, convergence,
and the command maps on BOTH DMs (DM2's stroke rings the Lyot-edge
image like DM1's) -- and the convergence panel overlays the DM1-only
loop, which stalls at 1.30e-7 (2.3x) where the pair reaches 8.05e-9.
New ctb_efc options: 'replot' (rebuild the figure from a saved
ctb_efc.mat, no engine, no loop) and 'compare' (overlay curve).
ctb_efc_dm1only.mat (1 KB) commits the DM1-only contrast history as
the curve's provenance. Deck slide 8: result bullet + caption carry
the comparison; rebuilt, slide QA'd.

Co-Authored-By: Claude Fable 5 <noreply@anthropic.com>
</commit_message>
<xml_diff>
--- a/mmacos/templates/30_instruments/bench_ctb/deck_ctb.pptx
+++ b/mmacos/templates/30_instruments/bench_ctb/deck_ctb.pptx
@@ -7860,7 +7860,7 @@
                 </a:solidFill>
                 <a:latin typeface="Arial"/>
               </a:rPr>
-              <a:t>•  Result: 2.9×10⁻⁷ → 8.1×10⁻⁹ (36×) in 19 iterations at 9.9/8.6 nm rms surface stroke. The best any linear solve of the measured matrix can reach is 4.5×10⁻⁹ at 11 nm — the loop lands within 2× of that with a matrix measured once at the flat state; re-measuring it around the corrected state is the next depth increment.</a:t>
+              <a:t>•  Result: 2.9×10⁻⁷ → 8.1×10⁻⁹ (36×) in 19 iterations at 9.9/8.6 nm rms surface stroke. The best any linear solve of the measured matrix can reach is 4.5×10⁻⁹ at 11 nm — the loop lands within 2× of that with a matrix measured once at the flat state; re-measuring it around the corrected state is the next depth increment. Restricted to DM1 alone, the same loop stalls at 1.3×10⁻⁷ (2.3×): the pupil mirror is phase-only control, and the full annulus also needs the amplitude lever the out-of-pupil DM2 supplies.</a:t>
             </a:r>
           </a:p>
           <a:p>
@@ -7897,8 +7897,8 @@
         </p:blipFill>
         <p:spPr>
           <a:xfrm>
-            <a:off x="2830010" y="3398520"/>
-            <a:ext cx="6531674" cy="1828292"/>
+            <a:off x="2682799" y="3992879"/>
+            <a:ext cx="6826095" cy="1526032"/>
           </a:xfrm>
           <a:prstGeom prst="rect">
             <a:avLst/>
@@ -7913,8 +7913,8 @@
         </p:nvSpPr>
         <p:spPr>
           <a:xfrm>
-            <a:off x="411480" y="5245100"/>
-            <a:ext cx="11368735" cy="229107"/>
+            <a:off x="411480" y="5537200"/>
+            <a:ext cx="11368735" cy="394208"/>
           </a:xfrm>
           <a:prstGeom prst="rect">
             <a:avLst/>
@@ -7939,7 +7939,7 @@
                 </a:solidFill>
                 <a:latin typeface="Arial"/>
               </a:rPr>
-              <a:t>Before and after at the camera, contrast versus iteration, and the DM1 stroke map; dashed circles mark the 3–15 λ/D zone.</a:t>
+              <a:t>Before and after at the camera; contrast versus iteration, with the DM1-only loop overlaid stalling two decades short; the stroke maps commanded on both DMs. Dashed circles mark the 3–15 λ/D zone.</a:t>
             </a:r>
           </a:p>
         </p:txBody>
@@ -7952,7 +7952,7 @@
         </p:nvSpPr>
         <p:spPr>
           <a:xfrm>
-            <a:off x="411480" y="5510784"/>
+            <a:off x="411480" y="5967984"/>
             <a:ext cx="11368735" cy="274320"/>
           </a:xfrm>
           <a:prstGeom prst="rect">

</xml_diff>

<commit_message>
bench_ctb: vortex Lyot sweep vs the fixed designs, on its own slide
ctb_vortex_lyot_sweep: dense Lyot-fraction grid (0.50-0.99, charges 4
and 6, 8x-binned masks) plotted as contrast vs throughput against the
committed APLC / band-limited / hard-occulter points (read from
ctb_mask_compare.mat -- same grid, annulus, normalization). Charge 4
under-runs every fixed design at every throughput: 0.60 stop = 8.8e-11
at 36% T, deeper than the APLC (2.1e-10 @ 27%) at more throughput with
no apodizer to fabricate; 0.90 = 8.0e-9 at 81% T. Past 0.90 the leak
ring arrives inside the stop -- useful dial range 0.50-0.90. Charge 4
runs ~4x deeper than charge 6 throughout (smaller pixel-averaged core).

Deck: new main slide 6 with the sweep figure (19 slides; downstream
slides renumbered, in-text references fixed). README run line; STATUS
SESSION 11 sweep block. ctb_vortex_matched.png regenerated on the
dense grid.

Co-Authored-By: Claude Fable 5 <noreply@anthropic.com>
</commit_message>
<xml_diff>
--- a/mmacos/templates/30_instruments/bench_ctb/deck_ctb.pptx
+++ b/mmacos/templates/30_instruments/bench_ctb/deck_ctb.pptx
@@ -23,6 +23,7 @@
     <p:sldId id="271" r:id="rId22"/>
     <p:sldId id="272" r:id="rId23"/>
     <p:sldId id="273" r:id="rId24"/>
+    <p:sldId id="274" r:id="rId25"/>
   </p:sldIdLst>
   <p:sldSz cx="12191695" cy="6858000" type="screen4x3"/>
   <p:notesSz cx="6858000" cy="9144000"/>
@@ -3267,7 +3268,7 @@
                 </a:solidFill>
                 <a:latin typeface="Arial"/>
               </a:rPr>
-              <a:t>9 — Next</a:t>
+              <a:t>9 — The deformable mirrors close the loop</a:t>
             </a:r>
           </a:p>
           <a:p>
@@ -3283,7 +3284,7 @@
                 </a:solidFill>
                 <a:latin typeface="Arial"/>
               </a:rPr>
-              <a:t>Toward a real coronagraph model, in dependency order</a:t>
+              <a:t>Electric-field conjugation on the model itself: dark-zone mean 2.9×10⁻⁷ → 8.1×10⁻⁹ (36×) at 10 nm strokes</a:t>
             </a:r>
           </a:p>
         </p:txBody>
@@ -3341,7 +3342,7 @@
         <p:spPr>
           <a:xfrm>
             <a:off x="411480" y="1298448"/>
-            <a:ext cx="11368735" cy="274320"/>
+            <a:ext cx="5806440" cy="274320"/>
           </a:xfrm>
           <a:prstGeom prst="rect">
             <a:avLst/>
@@ -3366,7 +3367,7 @@
                 </a:solidFill>
                 <a:latin typeface="Arial"/>
               </a:rPr>
-              <a:t>•  Real mirror surfaces. Add measured-quality surface error maps to each of the eight parabolas — random roughness with realistic spatial statistics — so the model scatters light the way real optics do.</a:t>
+              <a:t>•  The DMs become controllable surfaces: each carries a 256-point displacement grid in its own element frame, driven by a 32×32 actuator lattice through Gaussian influence functions (12% nearest-neighbor coupling, 0.67 mm pitch = beam/32; 880 actuators of each DM sit inside the beam).</a:t>
             </a:r>
           </a:p>
           <a:p>
@@ -3382,55 +3383,7 @@
                 </a:solidFill>
                 <a:latin typeface="Arial"/>
               </a:rPr>
-              <a:t>•  Deeper control. The native loop is delivered (slide 8); next come re-measuring the control matrix around the corrected state, image-based field estimation (pairwise probing), and driving the same DMs with FALCO, the community's standard wavefront-control software — the hybrid Lyot mask enters there, since its design comes from that control loop.</a:t>
-            </a:r>
-          </a:p>
-          <a:p>
-            <a:pPr>
-              <a:spcAft>
-                <a:spcPts val="600"/>
-              </a:spcAft>
-            </a:pPr>
-            <a:r>
-              <a:rPr sz="1200" b="0">
-                <a:solidFill>
-                  <a:srgbClr val="282828"/>
-                </a:solidFill>
-                <a:latin typeface="Arial"/>
-              </a:rPr>
-              <a:t>•  Motion over time. Apply alignment drifts as a time series and report contrast versus time — how long the dark zone survives between corrections, now measurable against the delivered control loop.</a:t>
-            </a:r>
-          </a:p>
-          <a:p>
-            <a:pPr>
-              <a:spcAft>
-                <a:spcPts val="600"/>
-              </a:spcAft>
-            </a:pPr>
-            <a:r>
-              <a:rPr sz="1200" b="0">
-                <a:solidFill>
-                  <a:srgbClr val="282828"/>
-                </a:solidFill>
-                <a:latin typeface="Arial"/>
-              </a:rPr>
-              <a:t>•  Polarized light. Propagate the two polarization components separately, with the phase and amplitude changes each mirror coating imposes; polarization sets the contrast floor no deformable mirror can correct.</a:t>
-            </a:r>
-          </a:p>
-          <a:p>
-            <a:pPr>
-              <a:spcAft>
-                <a:spcPts val="600"/>
-              </a:spcAft>
-            </a:pPr>
-            <a:r>
-              <a:rPr sz="1200" b="0">
-                <a:solidFill>
-                  <a:srgbClr val="282828"/>
-                </a:solidFill>
-                <a:latin typeface="Arial"/>
-              </a:rPr>
-              <a:t>•  Validation against testbed data — the capstone. Needs a named dataset from a real bench and the measured (not design) parameters that produced it.</a:t>
+              <a:t>•  The control matrix is measured, not modeled: every actuator is poked 2 nm and propagated through the full masked chain — 1760 pokes, 11 minutes — so the correction solve has no model error to exploit. Each iteration re-propagates the model, scores the measured contrast, picks the regularization by that measurement, and stops itself when no step improves.</a:t>
             </a:r>
           </a:p>
         </p:txBody>
@@ -3443,8 +3396,8 @@
         </p:nvSpPr>
         <p:spPr>
           <a:xfrm>
-            <a:off x="411480" y="4017264"/>
-            <a:ext cx="11368735" cy="274320"/>
+            <a:off x="6400800" y="1298448"/>
+            <a:ext cx="5394960" cy="274320"/>
           </a:xfrm>
           <a:prstGeom prst="rect">
             <a:avLst/>
@@ -3463,13 +3416,131 @@
               </a:spcAft>
             </a:pPr>
             <a:r>
+              <a:rPr sz="1200" b="0">
+                <a:solidFill>
+                  <a:srgbClr val="282828"/>
+                </a:solidFill>
+                <a:latin typeface="Arial"/>
+              </a:rPr>
+              <a:t>•  Result: 2.9×10⁻⁷ → 8.1×10⁻⁹ (36×) in 19 iterations at 9.9/8.6 nm rms surface stroke. The best any linear solve of the measured matrix can reach is 4.5×10⁻⁹ at 11 nm — the loop lands within 2× of that with a matrix measured once at the flat state; re-measuring it around the corrected state is the next depth increment. Restricted to DM1 alone, the same loop stalls at 1.3×10⁻⁷ (2.3×): the pupil mirror is phase-only control, and the full annulus also needs the amplitude lever the out-of-pupil DM2 supplies.</a:t>
+            </a:r>
+          </a:p>
+          <a:p>
+            <a:pPr>
+              <a:spcAft>
+                <a:spcPts val="600"/>
+              </a:spcAft>
+            </a:pPr>
+            <a:r>
+              <a:rPr sz="1200" b="0">
+                <a:solidFill>
+                  <a:srgbClr val="282828"/>
+                </a:solidFill>
+                <a:latin typeface="Arial"/>
+              </a:rPr>
+              <a:t>•  Where the correction works hardest: with the 50% Lyot stop, 32 actuators steer light cleanly to about 8 λ/D on the final image scale — the inner half of the zone deepens 40×, the outer 25×, and the largest strokes ring the Lyot edge image on the mirror.</a:t>
+            </a:r>
+          </a:p>
+        </p:txBody>
+      </p:sp>
+      <p:pic>
+        <p:nvPicPr>
+          <p:cNvPr id="6" name="Picture 5" descr="ctb_efc.png"/>
+          <p:cNvPicPr>
+            <a:picLocks noChangeAspect="1"/>
+          </p:cNvPicPr>
+          <p:nvPr/>
+        </p:nvPicPr>
+        <p:blipFill>
+          <a:blip r:embed="rId2"/>
+          <a:stretch>
+            <a:fillRect/>
+          </a:stretch>
+        </p:blipFill>
+        <p:spPr>
+          <a:xfrm>
+            <a:off x="2682799" y="3992879"/>
+            <a:ext cx="6826095" cy="1526032"/>
+          </a:xfrm>
+          <a:prstGeom prst="rect">
+            <a:avLst/>
+          </a:prstGeom>
+        </p:spPr>
+      </p:pic>
+      <p:sp>
+        <p:nvSpPr>
+          <p:cNvPr id="7" name="TextBox 6"/>
+          <p:cNvSpPr txBox="1"/>
+          <p:nvPr/>
+        </p:nvSpPr>
+        <p:spPr>
+          <a:xfrm>
+            <a:off x="411480" y="5537200"/>
+            <a:ext cx="11368735" cy="394208"/>
+          </a:xfrm>
+          <a:prstGeom prst="rect">
+            <a:avLst/>
+          </a:prstGeom>
+          <a:noFill/>
+        </p:spPr>
+        <p:txBody>
+          <a:bodyPr wrap="square">
+            <a:spAutoFit/>
+          </a:bodyPr>
+          <a:lstStyle/>
+          <a:p>
+            <a:pPr algn="ctr">
+              <a:spcAft>
+                <a:spcPts val="0"/>
+              </a:spcAft>
+            </a:pPr>
+            <a:r>
+              <a:rPr sz="1000" b="0">
+                <a:solidFill>
+                  <a:srgbClr val="6E6E6E"/>
+                </a:solidFill>
+                <a:latin typeface="Arial"/>
+              </a:rPr>
+              <a:t>Before and after at the camera; contrast versus iteration, with the DM1-only loop overlaid stalling two decades short; the stroke maps commanded on both DMs. Dashed circles mark the 3–15 λ/D zone.</a:t>
+            </a:r>
+          </a:p>
+        </p:txBody>
+      </p:sp>
+      <p:sp>
+        <p:nvSpPr>
+          <p:cNvPr id="8" name="TextBox 7"/>
+          <p:cNvSpPr txBox="1"/>
+          <p:nvPr/>
+        </p:nvSpPr>
+        <p:spPr>
+          <a:xfrm>
+            <a:off x="411480" y="5967984"/>
+            <a:ext cx="11368735" cy="274320"/>
+          </a:xfrm>
+          <a:prstGeom prst="rect">
+            <a:avLst/>
+          </a:prstGeom>
+          <a:noFill/>
+        </p:spPr>
+        <p:txBody>
+          <a:bodyPr wrap="square">
+            <a:spAutoFit/>
+          </a:bodyPr>
+          <a:lstStyle/>
+          <a:p>
+            <a:pPr>
+              <a:spcAft>
+                <a:spcPts val="600"/>
+              </a:spcAft>
+            </a:pPr>
+            <a:r>
               <a:rPr sz="1050" b="0">
                 <a:solidFill>
                   <a:srgbClr val="6E6E6E"/>
                 </a:solidFill>
                 <a:latin typeface="Arial"/>
               </a:rPr>
-              <a:t>Mechanical layer delivered and merged: a prescription generator that reproduces both hand-built models to round-off, regression tests pinning the validated numbers (two suites, 16 checks green), the example README, and the exit-pupil-finder guard in the engine (pushed).</a:t>
+              <a:t>Sensing is assumed perfect — the loop reads the model's complex field directly. Estimating that field from camera images alone (pairwise probing, as a testbed must) is the next layer of realism.</a:t>
             </a:r>
           </a:p>
         </p:txBody>
@@ -3526,7 +3597,7 @@
                 </a:solidFill>
                 <a:latin typeface="Arial"/>
               </a:rPr>
-              <a:t>10 — References</a:t>
+              <a:t>10 — Next</a:t>
             </a:r>
           </a:p>
           <a:p>
@@ -3542,7 +3613,7 @@
                 </a:solidFill>
                 <a:latin typeface="Arial"/>
               </a:rPr>
-              <a:t>Sources for the mask families and the control method; every formula taken from the paper itself</a:t>
+              <a:t>Toward a real coronagraph model, in dependency order</a:t>
             </a:r>
           </a:p>
         </p:txBody>
@@ -3625,7 +3696,7 @@
                 </a:solidFill>
                 <a:latin typeface="Arial"/>
               </a:rPr>
-              <a:t>•  Band-limited masks: Kuchner &amp; Traub 2002, ApJ 570, 900 (4th order); Kuchner, Crepp &amp; Ge 2005, ApJ 628, 466 (8th order).</a:t>
+              <a:t>•  Real mirror surfaces. Add measured-quality surface error maps to each of the eight parabolas — random roughness with realistic spatial statistics — so the model scatters light the way real optics do.</a:t>
             </a:r>
           </a:p>
           <a:p>
@@ -3641,7 +3712,7 @@
                 </a:solidFill>
                 <a:latin typeface="Arial"/>
               </a:rPr>
-              <a:t>•  Apodized-pupil Lyot: Soummer 2005, ApJ 618, L161 (the prolate apodizer); Soummer et al. 2011, ApJ 729, 144 (the GPI instrument configuration used here).</a:t>
+              <a:t>•  Deeper control. The native loop is delivered (slide 9); next come re-measuring the control matrix around the corrected state, image-based field estimation (pairwise probing), and driving the same DMs with FALCO, the community's standard wavefront-control software — the hybrid Lyot mask enters there, since its design comes from that control loop.</a:t>
             </a:r>
           </a:p>
           <a:p>
@@ -3657,7 +3728,7 @@
                 </a:solidFill>
                 <a:latin typeface="Arial"/>
               </a:rPr>
-              <a:t>•  Phase masks: Roddier &amp; Roddier 1997, PASP 109, 815 (the π-spot); N'Diaye et al. 2012, A&amp;A 538, A55 (the achromatic dual-zone); Soummer, Dohlen &amp; Aime 2003, A&amp;A 403, 369.</a:t>
+              <a:t>•  Motion over time. Apply alignment drifts as a time series and report contrast versus time — how long the dark zone survives between corrections, now measurable against the delivered control loop.</a:t>
             </a:r>
           </a:p>
           <a:p>
@@ -3673,7 +3744,7 @@
                 </a:solidFill>
                 <a:latin typeface="Arial"/>
               </a:rPr>
-              <a:t>•  Vortex: Mawet et al. 2005, ApJ 633, 1191; Foo, Palacios &amp; Swartzlander 2005, Opt. Lett. 30, 3308; Jenkins 2008, MNRAS 384, 515 (the even-charge rejection property).</a:t>
+              <a:t>•  Polarized light. Propagate the two polarization components separately, with the phase and amplitude changes each mirror coating imposes; polarization sets the contrast floor no deformable mirror can correct.</a:t>
             </a:r>
           </a:p>
           <a:p>
@@ -3689,23 +3760,7 @@
                 </a:solidFill>
                 <a:latin typeface="Arial"/>
               </a:rPr>
-              <a:t>•  Wavefront control: Give'on et al. 2007, Proc. SPIE 6691 (electric-field conjugation, the correction solve of slide 8).</a:t>
-            </a:r>
-          </a:p>
-          <a:p>
-            <a:pPr>
-              <a:spcAft>
-                <a:spcPts val="600"/>
-              </a:spcAft>
-            </a:pPr>
-            <a:r>
-              <a:rPr sz="1200" b="0">
-                <a:solidFill>
-                  <a:srgbClr val="282828"/>
-                </a:solidFill>
-                <a:latin typeface="Arial"/>
-              </a:rPr>
-              <a:t>•  Diffraction reference code: PROPER — Krist 2007, Proc. SPIE 6675 (the arbiter for every propagation cross-check in this deck).</a:t>
+              <a:t>•  Validation against testbed data — the capstone. Needs a named dataset from a real bench and the measured (not design) parameters that produced it.</a:t>
             </a:r>
           </a:p>
         </p:txBody>
@@ -3718,7 +3773,7 @@
         </p:nvSpPr>
         <p:spPr>
           <a:xfrm>
-            <a:off x="411480" y="3959352"/>
+            <a:off x="411480" y="4017264"/>
             <a:ext cx="11368735" cy="274320"/>
           </a:xfrm>
           <a:prstGeom prst="rect">
@@ -3744,7 +3799,7 @@
                 </a:solidFill>
                 <a:latin typeface="Arial"/>
               </a:rPr>
-              <a:t>A companion three-slide deck (ctb_mask_families, committed beside the drivers) carries the code map: which script builds which mask, and the parameters a user can change.</a:t>
+              <a:t>Mechanical layer delivered and merged: a prescription generator that reproduces both hand-built models to round-off, regression tests pinning the validated numbers (two suites, 16 checks green), the example README, and the exit-pupil-finder guard in the engine (pushed).</a:t>
             </a:r>
           </a:p>
         </p:txBody>
@@ -3801,7 +3856,23 @@
                 </a:solidFill>
                 <a:latin typeface="Arial"/>
               </a:rPr>
-              <a:t>Backup Slides</a:t>
+              <a:t>11 — References</a:t>
+            </a:r>
+          </a:p>
+          <a:p>
+            <a:pPr>
+              <a:spcAft>
+                <a:spcPts val="0"/>
+              </a:spcAft>
+            </a:pPr>
+            <a:r>
+              <a:rPr sz="1250" b="0">
+                <a:solidFill>
+                  <a:srgbClr val="6E6E6E"/>
+                </a:solidFill>
+                <a:latin typeface="Arial"/>
+              </a:rPr>
+              <a:t>Sources for the mask families and the control method; every formula taken from the paper itself</a:t>
             </a:r>
           </a:p>
         </p:txBody>
@@ -3814,7 +3885,7 @@
         </p:nvSpPr>
         <p:spPr>
           <a:xfrm>
-            <a:off x="411480" y="914400"/>
+            <a:off x="411480" y="1133856"/>
             <a:ext cx="11368735" cy="20320"/>
           </a:xfrm>
           <a:prstGeom prst="rect">
@@ -3858,7 +3929,7 @@
         </p:nvSpPr>
         <p:spPr>
           <a:xfrm>
-            <a:off x="411480" y="1078992"/>
+            <a:off x="411480" y="1298448"/>
             <a:ext cx="11368735" cy="274320"/>
           </a:xfrm>
           <a:prstGeom prst="rect">
@@ -3884,7 +3955,126 @@
                 </a:solidFill>
                 <a:latin typeface="Arial"/>
               </a:rPr>
-              <a:t>•  Galleries, per-family detail, the per-leg replay check, and the control-loop diagnostics.</a:t>
+              <a:t>•  Band-limited masks: Kuchner &amp; Traub 2002, ApJ 570, 900 (4th order); Kuchner, Crepp &amp; Ge 2005, ApJ 628, 466 (8th order).</a:t>
+            </a:r>
+          </a:p>
+          <a:p>
+            <a:pPr>
+              <a:spcAft>
+                <a:spcPts val="600"/>
+              </a:spcAft>
+            </a:pPr>
+            <a:r>
+              <a:rPr sz="1200" b="0">
+                <a:solidFill>
+                  <a:srgbClr val="282828"/>
+                </a:solidFill>
+                <a:latin typeface="Arial"/>
+              </a:rPr>
+              <a:t>•  Apodized-pupil Lyot: Soummer 2005, ApJ 618, L161 (the prolate apodizer); Soummer et al. 2011, ApJ 729, 144 (the GPI instrument configuration used here).</a:t>
+            </a:r>
+          </a:p>
+          <a:p>
+            <a:pPr>
+              <a:spcAft>
+                <a:spcPts val="600"/>
+              </a:spcAft>
+            </a:pPr>
+            <a:r>
+              <a:rPr sz="1200" b="0">
+                <a:solidFill>
+                  <a:srgbClr val="282828"/>
+                </a:solidFill>
+                <a:latin typeface="Arial"/>
+              </a:rPr>
+              <a:t>•  Phase masks: Roddier &amp; Roddier 1997, PASP 109, 815 (the π-spot); N'Diaye et al. 2012, A&amp;A 538, A55 (the achromatic dual-zone); Soummer, Dohlen &amp; Aime 2003, A&amp;A 403, 369.</a:t>
+            </a:r>
+          </a:p>
+          <a:p>
+            <a:pPr>
+              <a:spcAft>
+                <a:spcPts val="600"/>
+              </a:spcAft>
+            </a:pPr>
+            <a:r>
+              <a:rPr sz="1200" b="0">
+                <a:solidFill>
+                  <a:srgbClr val="282828"/>
+                </a:solidFill>
+                <a:latin typeface="Arial"/>
+              </a:rPr>
+              <a:t>•  Vortex: Mawet et al. 2005, ApJ 633, 1191; Foo, Palacios &amp; Swartzlander 2005, Opt. Lett. 30, 3308; Jenkins 2008, MNRAS 384, 515 (the even-charge rejection property).</a:t>
+            </a:r>
+          </a:p>
+          <a:p>
+            <a:pPr>
+              <a:spcAft>
+                <a:spcPts val="600"/>
+              </a:spcAft>
+            </a:pPr>
+            <a:r>
+              <a:rPr sz="1200" b="0">
+                <a:solidFill>
+                  <a:srgbClr val="282828"/>
+                </a:solidFill>
+                <a:latin typeface="Arial"/>
+              </a:rPr>
+              <a:t>•  Wavefront control: Give'on et al. 2007, Proc. SPIE 6691 (electric-field conjugation, the correction solve of slide 9).</a:t>
+            </a:r>
+          </a:p>
+          <a:p>
+            <a:pPr>
+              <a:spcAft>
+                <a:spcPts val="600"/>
+              </a:spcAft>
+            </a:pPr>
+            <a:r>
+              <a:rPr sz="1200" b="0">
+                <a:solidFill>
+                  <a:srgbClr val="282828"/>
+                </a:solidFill>
+                <a:latin typeface="Arial"/>
+              </a:rPr>
+              <a:t>•  Diffraction reference code: PROPER — Krist 2007, Proc. SPIE 6675 (the arbiter for every propagation cross-check in this deck).</a:t>
+            </a:r>
+          </a:p>
+        </p:txBody>
+      </p:sp>
+      <p:sp>
+        <p:nvSpPr>
+          <p:cNvPr id="5" name="TextBox 4"/>
+          <p:cNvSpPr txBox="1"/>
+          <p:nvPr/>
+        </p:nvSpPr>
+        <p:spPr>
+          <a:xfrm>
+            <a:off x="411480" y="3959352"/>
+            <a:ext cx="11368735" cy="274320"/>
+          </a:xfrm>
+          <a:prstGeom prst="rect">
+            <a:avLst/>
+          </a:prstGeom>
+          <a:noFill/>
+        </p:spPr>
+        <p:txBody>
+          <a:bodyPr wrap="square">
+            <a:spAutoFit/>
+          </a:bodyPr>
+          <a:lstStyle/>
+          <a:p>
+            <a:pPr>
+              <a:spcAft>
+                <a:spcPts val="600"/>
+              </a:spcAft>
+            </a:pPr>
+            <a:r>
+              <a:rPr sz="1050" b="0">
+                <a:solidFill>
+                  <a:srgbClr val="6E6E6E"/>
+                </a:solidFill>
+                <a:latin typeface="Arial"/>
+              </a:rPr>
+              <a:t>A companion three-slide deck (ctb_mask_families, committed beside the drivers) carries the code map: which script builds which mask, and the parameters a user can change.</a:t>
             </a:r>
           </a:p>
         </p:txBody>
@@ -3941,23 +4131,7 @@
                 </a:solidFill>
                 <a:latin typeface="Arial"/>
               </a:rPr>
-              <a:t>The mask families, one by one (1 of 2)</a:t>
-            </a:r>
-          </a:p>
-          <a:p>
-            <a:pPr>
-              <a:spcAft>
-                <a:spcPts val="0"/>
-              </a:spcAft>
-            </a:pPr>
-            <a:r>
-              <a:rPr sz="1250" b="0">
-                <a:solidFill>
-                  <a:srgbClr val="6E6E6E"/>
-                </a:solidFill>
-                <a:latin typeface="Arial"/>
-              </a:rPr>
-              <a:t>Apodized-pupil Lyot and band-limited</a:t>
+              <a:t>Backup Slides</a:t>
             </a:r>
           </a:p>
         </p:txBody>
@@ -3970,7 +4144,7 @@
         </p:nvSpPr>
         <p:spPr>
           <a:xfrm>
-            <a:off x="411480" y="1133856"/>
+            <a:off x="411480" y="914400"/>
             <a:ext cx="11368735" cy="20320"/>
           </a:xfrm>
           <a:prstGeom prst="rect">
@@ -4006,40 +4180,16 @@
           </a:p>
         </p:txBody>
       </p:sp>
-      <p:pic>
-        <p:nvPicPr>
-          <p:cNvPr id="4" name="Picture 3" descr="ctb_aplc.png"/>
-          <p:cNvPicPr>
-            <a:picLocks noChangeAspect="1"/>
-          </p:cNvPicPr>
-          <p:nvPr/>
-        </p:nvPicPr>
-        <p:blipFill>
-          <a:blip r:embed="rId2"/>
-          <a:stretch>
-            <a:fillRect/>
-          </a:stretch>
-        </p:blipFill>
-        <p:spPr>
-          <a:xfrm>
-            <a:off x="1404046" y="1298448"/>
-            <a:ext cx="3821307" cy="2440432"/>
-          </a:xfrm>
-          <a:prstGeom prst="rect">
-            <a:avLst/>
-          </a:prstGeom>
-        </p:spPr>
-      </p:pic>
-      <p:sp>
-        <p:nvSpPr>
-          <p:cNvPr id="5" name="TextBox 4"/>
+      <p:sp>
+        <p:nvSpPr>
+          <p:cNvPr id="4" name="TextBox 3"/>
           <p:cNvSpPr txBox="1"/>
           <p:nvPr/>
         </p:nvSpPr>
         <p:spPr>
           <a:xfrm>
-            <a:off x="411480" y="3757167"/>
-            <a:ext cx="5806440" cy="394208"/>
+            <a:off x="411480" y="1078992"/>
+            <a:ext cx="11368735" cy="274320"/>
           </a:xfrm>
           <a:prstGeom prst="rect">
             <a:avLst/>
@@ -4052,82 +4202,19 @@
           </a:bodyPr>
           <a:lstStyle/>
           <a:p>
-            <a:pPr algn="ctr">
-              <a:spcAft>
-                <a:spcPts val="0"/>
-              </a:spcAft>
-            </a:pPr>
-            <a:r>
-              <a:rPr sz="1000" b="0">
-                <a:solidFill>
-                  <a:srgbClr val="6E6E6E"/>
-                </a:solidFill>
-                <a:latin typeface="Arial"/>
-              </a:rPr>
-              <a:t>The apodized-pupil Lyot configuration: prolate apodizer, occulter, Lyot stop, and its dark zone.</a:t>
-            </a:r>
-          </a:p>
-        </p:txBody>
-      </p:sp>
-      <p:pic>
-        <p:nvPicPr>
-          <p:cNvPr id="6" name="Picture 5" descr="ctb_bandlimited.png"/>
-          <p:cNvPicPr>
-            <a:picLocks noChangeAspect="1"/>
-          </p:cNvPicPr>
-          <p:nvPr/>
-        </p:nvPicPr>
-        <p:blipFill>
-          <a:blip r:embed="rId3"/>
-          <a:stretch>
-            <a:fillRect/>
-          </a:stretch>
-        </p:blipFill>
-        <p:spPr>
-          <a:xfrm>
-            <a:off x="6957009" y="1298448"/>
-            <a:ext cx="4282541" cy="2605532"/>
-          </a:xfrm>
-          <a:prstGeom prst="rect">
-            <a:avLst/>
-          </a:prstGeom>
-        </p:spPr>
-      </p:pic>
-      <p:sp>
-        <p:nvSpPr>
-          <p:cNvPr id="7" name="TextBox 6"/>
-          <p:cNvSpPr txBox="1"/>
-          <p:nvPr/>
-        </p:nvSpPr>
-        <p:spPr>
-          <a:xfrm>
-            <a:off x="6400800" y="3922267"/>
-            <a:ext cx="5394960" cy="229107"/>
-          </a:xfrm>
-          <a:prstGeom prst="rect">
-            <a:avLst/>
-          </a:prstGeom>
-          <a:noFill/>
-        </p:spPr>
-        <p:txBody>
-          <a:bodyPr wrap="square">
-            <a:spAutoFit/>
-          </a:bodyPr>
-          <a:lstStyle/>
-          <a:p>
-            <a:pPr algn="ctr">
-              <a:spcAft>
-                <a:spcPts val="0"/>
-              </a:spcAft>
-            </a:pPr>
-            <a:r>
-              <a:rPr sz="1000" b="0">
-                <a:solidFill>
-                  <a:srgbClr val="6E6E6E"/>
-                </a:solidFill>
-                <a:latin typeface="Arial"/>
-              </a:rPr>
-              <a:t>The 4th-order band-limited mask: amplitude profile and its dark zone.</a:t>
+            <a:pPr>
+              <a:spcAft>
+                <a:spcPts val="600"/>
+              </a:spcAft>
+            </a:pPr>
+            <a:r>
+              <a:rPr sz="1200" b="0">
+                <a:solidFill>
+                  <a:srgbClr val="282828"/>
+                </a:solidFill>
+                <a:latin typeface="Arial"/>
+              </a:rPr>
+              <a:t>•  Galleries, per-family detail, the per-leg replay check, and the control-loop diagnostics.</a:t>
             </a:r>
           </a:p>
         </p:txBody>
@@ -4184,7 +4271,7 @@
                 </a:solidFill>
                 <a:latin typeface="Arial"/>
               </a:rPr>
-              <a:t>The mask families, one by one (2 of 2)</a:t>
+              <a:t>The mask families, one by one (1 of 2)</a:t>
             </a:r>
           </a:p>
           <a:p>
@@ -4200,7 +4287,7 @@
                 </a:solidFill>
                 <a:latin typeface="Arial"/>
               </a:rPr>
-              <a:t>Phase masks and the vortex</a:t>
+              <a:t>Apodized-pupil Lyot and band-limited</a:t>
             </a:r>
           </a:p>
         </p:txBody>
@@ -4251,7 +4338,7 @@
       </p:sp>
       <p:pic>
         <p:nvPicPr>
-          <p:cNvPr id="4" name="Picture 3" descr="ctb_phase_masks.png"/>
+          <p:cNvPr id="4" name="Picture 3" descr="ctb_aplc.png"/>
           <p:cNvPicPr>
             <a:picLocks noChangeAspect="1"/>
           </p:cNvPicPr>
@@ -4265,8 +4352,8 @@
         </p:blipFill>
         <p:spPr>
           <a:xfrm>
-            <a:off x="1426422" y="1298448"/>
-            <a:ext cx="3776554" cy="2440432"/>
+            <a:off x="1404046" y="1298448"/>
+            <a:ext cx="3821307" cy="2440432"/>
           </a:xfrm>
           <a:prstGeom prst="rect">
             <a:avLst/>
@@ -4307,14 +4394,14 @@
                 </a:solidFill>
                 <a:latin typeface="Arial"/>
               </a:rPr>
-              <a:t>The Roddier π-spot and dual-zone phase masks; both need their matched entrance apodizer to go deep.</a:t>
+              <a:t>The apodized-pupil Lyot configuration: prolate apodizer, occulter, Lyot stop, and its dark zone.</a:t>
             </a:r>
           </a:p>
         </p:txBody>
       </p:sp>
       <p:pic>
         <p:nvPicPr>
-          <p:cNvPr id="6" name="Picture 5" descr="ctb_vortex_matched.png"/>
+          <p:cNvPr id="6" name="Picture 5" descr="ctb_bandlimited.png"/>
           <p:cNvPicPr>
             <a:picLocks noChangeAspect="1"/>
           </p:cNvPicPr>
@@ -4328,8 +4415,8 @@
         </p:blipFill>
         <p:spPr>
           <a:xfrm>
-            <a:off x="7057750" y="1298448"/>
-            <a:ext cx="4081058" cy="2440432"/>
+            <a:off x="6957009" y="1298448"/>
+            <a:ext cx="4282541" cy="2605532"/>
           </a:xfrm>
           <a:prstGeom prst="rect">
             <a:avLst/>
@@ -4344,8 +4431,8 @@
         </p:nvSpPr>
         <p:spPr>
           <a:xfrm>
-            <a:off x="6400800" y="3757167"/>
-            <a:ext cx="5394960" cy="394208"/>
+            <a:off x="6400800" y="3922267"/>
+            <a:ext cx="5394960" cy="229107"/>
           </a:xfrm>
           <a:prstGeom prst="rect">
             <a:avLst/>
@@ -4370,7 +4457,7 @@
                 </a:solidFill>
                 <a:latin typeface="Arial"/>
               </a:rPr>
-              <a:t>The vortex with matched Lyot: even winding number on a clear pupil sends starlight outside the reimaged pupil.</a:t>
+              <a:t>The 4th-order band-limited mask: amplitude profile and its dark zone.</a:t>
             </a:r>
           </a:p>
         </p:txBody>
@@ -4384,6 +4471,249 @@
 </file>
 
 <file path=ppt/slides/slide15.xml><?xml version="1.0" encoding="utf-8"?>
+<p:sld xmlns:a="http://schemas.openxmlformats.org/drawingml/2006/main" xmlns:p="http://schemas.openxmlformats.org/presentationml/2006/main" xmlns:r="http://schemas.openxmlformats.org/officeDocument/2006/relationships">
+  <p:cSld>
+    <p:spTree>
+      <p:nvGrpSpPr>
+        <p:cNvPr id="1" name=""/>
+        <p:cNvGrpSpPr/>
+        <p:nvPr/>
+      </p:nvGrpSpPr>
+      <p:grpSpPr/>
+      <p:sp>
+        <p:nvSpPr>
+          <p:cNvPr id="2" name="TextBox 1"/>
+          <p:cNvSpPr txBox="1"/>
+          <p:nvPr/>
+        </p:nvSpPr>
+        <p:spPr>
+          <a:xfrm>
+            <a:off x="411480" y="201168"/>
+            <a:ext cx="11368735" cy="914400"/>
+          </a:xfrm>
+          <a:prstGeom prst="rect">
+            <a:avLst/>
+          </a:prstGeom>
+          <a:noFill/>
+        </p:spPr>
+        <p:txBody>
+          <a:bodyPr wrap="square">
+            <a:spAutoFit/>
+          </a:bodyPr>
+          <a:lstStyle/>
+          <a:p>
+            <a:pPr>
+              <a:spcAft>
+                <a:spcPts val="400"/>
+              </a:spcAft>
+            </a:pPr>
+            <a:r>
+              <a:rPr sz="2400" b="1">
+                <a:solidFill>
+                  <a:srgbClr val="1F4E79"/>
+                </a:solidFill>
+                <a:latin typeface="Arial"/>
+              </a:rPr>
+              <a:t>The mask families, one by one (2 of 2)</a:t>
+            </a:r>
+          </a:p>
+          <a:p>
+            <a:pPr>
+              <a:spcAft>
+                <a:spcPts val="0"/>
+              </a:spcAft>
+            </a:pPr>
+            <a:r>
+              <a:rPr sz="1250" b="0">
+                <a:solidFill>
+                  <a:srgbClr val="6E6E6E"/>
+                </a:solidFill>
+                <a:latin typeface="Arial"/>
+              </a:rPr>
+              <a:t>Phase masks and the vortex</a:t>
+            </a:r>
+          </a:p>
+        </p:txBody>
+      </p:sp>
+      <p:sp>
+        <p:nvSpPr>
+          <p:cNvPr id="3" name="Rectangle 2"/>
+          <p:cNvSpPr/>
+          <p:nvPr/>
+        </p:nvSpPr>
+        <p:spPr>
+          <a:xfrm>
+            <a:off x="411480" y="1133856"/>
+            <a:ext cx="11368735" cy="20320"/>
+          </a:xfrm>
+          <a:prstGeom prst="rect">
+            <a:avLst/>
+          </a:prstGeom>
+          <a:solidFill>
+            <a:srgbClr val="B8C6D4"/>
+          </a:solidFill>
+          <a:ln>
+            <a:noFill/>
+          </a:ln>
+          <a:effectLst/>
+        </p:spPr>
+        <p:style>
+          <a:lnRef idx="1">
+            <a:schemeClr val="accent1"/>
+          </a:lnRef>
+          <a:fillRef idx="3">
+            <a:schemeClr val="accent1"/>
+          </a:fillRef>
+          <a:effectRef idx="2">
+            <a:schemeClr val="accent1"/>
+          </a:effectRef>
+          <a:fontRef idx="minor">
+            <a:schemeClr val="lt1"/>
+          </a:fontRef>
+        </p:style>
+        <p:txBody>
+          <a:bodyPr rtlCol="0" anchor="ctr"/>
+          <a:lstStyle/>
+          <a:p>
+            <a:pPr algn="ctr"/>
+          </a:p>
+        </p:txBody>
+      </p:sp>
+      <p:pic>
+        <p:nvPicPr>
+          <p:cNvPr id="4" name="Picture 3" descr="ctb_phase_masks.png"/>
+          <p:cNvPicPr>
+            <a:picLocks noChangeAspect="1"/>
+          </p:cNvPicPr>
+          <p:nvPr/>
+        </p:nvPicPr>
+        <p:blipFill>
+          <a:blip r:embed="rId2"/>
+          <a:stretch>
+            <a:fillRect/>
+          </a:stretch>
+        </p:blipFill>
+        <p:spPr>
+          <a:xfrm>
+            <a:off x="1426422" y="1298448"/>
+            <a:ext cx="3776554" cy="2440432"/>
+          </a:xfrm>
+          <a:prstGeom prst="rect">
+            <a:avLst/>
+          </a:prstGeom>
+        </p:spPr>
+      </p:pic>
+      <p:sp>
+        <p:nvSpPr>
+          <p:cNvPr id="5" name="TextBox 4"/>
+          <p:cNvSpPr txBox="1"/>
+          <p:nvPr/>
+        </p:nvSpPr>
+        <p:spPr>
+          <a:xfrm>
+            <a:off x="411480" y="3757167"/>
+            <a:ext cx="5806440" cy="394208"/>
+          </a:xfrm>
+          <a:prstGeom prst="rect">
+            <a:avLst/>
+          </a:prstGeom>
+          <a:noFill/>
+        </p:spPr>
+        <p:txBody>
+          <a:bodyPr wrap="square">
+            <a:spAutoFit/>
+          </a:bodyPr>
+          <a:lstStyle/>
+          <a:p>
+            <a:pPr algn="ctr">
+              <a:spcAft>
+                <a:spcPts val="0"/>
+              </a:spcAft>
+            </a:pPr>
+            <a:r>
+              <a:rPr sz="1000" b="0">
+                <a:solidFill>
+                  <a:srgbClr val="6E6E6E"/>
+                </a:solidFill>
+                <a:latin typeface="Arial"/>
+              </a:rPr>
+              <a:t>The Roddier π-spot and dual-zone phase masks; both need their matched entrance apodizer to go deep.</a:t>
+            </a:r>
+          </a:p>
+        </p:txBody>
+      </p:sp>
+      <p:pic>
+        <p:nvPicPr>
+          <p:cNvPr id="6" name="Picture 5" descr="ctb_vortex_matched.png"/>
+          <p:cNvPicPr>
+            <a:picLocks noChangeAspect="1"/>
+          </p:cNvPicPr>
+          <p:nvPr/>
+        </p:nvPicPr>
+        <p:blipFill>
+          <a:blip r:embed="rId3"/>
+          <a:stretch>
+            <a:fillRect/>
+          </a:stretch>
+        </p:blipFill>
+        <p:spPr>
+          <a:xfrm>
+            <a:off x="7057750" y="1298448"/>
+            <a:ext cx="4081058" cy="2440432"/>
+          </a:xfrm>
+          <a:prstGeom prst="rect">
+            <a:avLst/>
+          </a:prstGeom>
+        </p:spPr>
+      </p:pic>
+      <p:sp>
+        <p:nvSpPr>
+          <p:cNvPr id="7" name="TextBox 6"/>
+          <p:cNvSpPr txBox="1"/>
+          <p:nvPr/>
+        </p:nvSpPr>
+        <p:spPr>
+          <a:xfrm>
+            <a:off x="6400800" y="3757167"/>
+            <a:ext cx="5394960" cy="394208"/>
+          </a:xfrm>
+          <a:prstGeom prst="rect">
+            <a:avLst/>
+          </a:prstGeom>
+          <a:noFill/>
+        </p:spPr>
+        <p:txBody>
+          <a:bodyPr wrap="square">
+            <a:spAutoFit/>
+          </a:bodyPr>
+          <a:lstStyle/>
+          <a:p>
+            <a:pPr algn="ctr">
+              <a:spcAft>
+                <a:spcPts val="0"/>
+              </a:spcAft>
+            </a:pPr>
+            <a:r>
+              <a:rPr sz="1000" b="0">
+                <a:solidFill>
+                  <a:srgbClr val="6E6E6E"/>
+                </a:solidFill>
+                <a:latin typeface="Arial"/>
+              </a:rPr>
+              <a:t>The vortex with matched Lyot: even winding number on a clear pupil sends starlight outside the reimaged pupil.</a:t>
+            </a:r>
+          </a:p>
+        </p:txBody>
+      </p:sp>
+    </p:spTree>
+  </p:cSld>
+  <p:clrMapOvr>
+    <a:masterClrMapping/>
+  </p:clrMapOvr>
+</p:sld>
+</file>
+
+<file path=ppt/slides/slide16.xml><?xml version="1.0" encoding="utf-8"?>
 <p:sld xmlns:a="http://schemas.openxmlformats.org/drawingml/2006/main" xmlns:p="http://schemas.openxmlformats.org/presentationml/2006/main" xmlns:r="http://schemas.openxmlformats.org/officeDocument/2006/relationships">
   <p:cSld>
     <p:spTree>
@@ -5037,7 +5367,7 @@
 </p:sld>
 </file>
 
-<file path=ppt/slides/slide16.xml><?xml version="1.0" encoding="utf-8"?>
+<file path=ppt/slides/slide17.xml><?xml version="1.0" encoding="utf-8"?>
 <p:sld xmlns:a="http://schemas.openxmlformats.org/drawingml/2006/main" xmlns:p="http://schemas.openxmlformats.org/presentationml/2006/main" xmlns:r="http://schemas.openxmlformats.org/officeDocument/2006/relationships">
   <p:cSld>
     <p:spTree>
@@ -5280,7 +5610,7 @@
 </p:sld>
 </file>
 
-<file path=ppt/slides/slide17.xml><?xml version="1.0" encoding="utf-8"?>
+<file path=ppt/slides/slide18.xml><?xml version="1.0" encoding="utf-8"?>
 <p:sld xmlns:a="http://schemas.openxmlformats.org/drawingml/2006/main" xmlns:p="http://schemas.openxmlformats.org/presentationml/2006/main" xmlns:r="http://schemas.openxmlformats.org/officeDocument/2006/relationships">
   <p:cSld>
     <p:spTree>
@@ -5460,7 +5790,7 @@
 </p:sld>
 </file>
 
-<file path=ppt/slides/slide18.xml><?xml version="1.0" encoding="utf-8"?>
+<file path=ppt/slides/slide19.xml><?xml version="1.0" encoding="utf-8"?>
 <p:sld xmlns:a="http://schemas.openxmlformats.org/drawingml/2006/main" xmlns:p="http://schemas.openxmlformats.org/presentationml/2006/main" xmlns:r="http://schemas.openxmlformats.org/officeDocument/2006/relationships">
   <p:cSld>
     <p:spTree>
@@ -7772,7 +8102,7 @@
                 </a:solidFill>
                 <a:latin typeface="Arial"/>
               </a:rPr>
-              <a:t>6 — Phase-factor export</a:t>
+              <a:t>6 — The vortex against the Lyot stop</a:t>
             </a:r>
           </a:p>
           <a:p>
@@ -7788,7 +8118,7 @@
                 </a:solidFill>
                 <a:latin typeface="Arial"/>
               </a:rPr>
-              <a:t>External PROPER models can consume this model's planes, and check theirs against ours station by station</a:t>
+              <a:t>Charge 4 under-runs every fixed design at every throughput: 8.8×10⁻¹¹ at the band-limited mask's own 36%</a:t>
             </a:r>
           </a:p>
         </p:txBody>
@@ -7871,7 +8201,7 @@
                 </a:solidFill>
                 <a:latin typeface="Arial"/>
               </a:rPr>
-              <a:t>•  One self-describing file carries the full 44-element model: 18 stations (complex field, amplitude, OPD, grid pitch, all in metres), the 17 propagation legs, the 4 reference spheres, and 18 per-plane phase screens — with the sign, orientation, and centering conventions stamped inside. The orientation is measured, not asserted: a +X pupil phase ramp lands the image peak where the file says it will.</a:t>
+              <a:t>•  One mask, one dial: the vortex phase mask is fixed; only the Lyot stop fraction moves. Every point shares the head-to-head's grid, annulus (3–15 λ/D), and normalization, and the fixed-design markers are read from the committed comparison — the same footing, no re-scoring.</a:t>
             </a:r>
           </a:p>
           <a:p>
@@ -7887,7 +8217,7 @@
                 </a:solidFill>
                 <a:latin typeface="Arial"/>
               </a:rPr>
-              <a:t>•  A companion PROPER run script reads only the exported file — no macos — and replays the model two ways: every leg propagated, or handing off at the exported fields. Focus stations reproduce at correlation 1.000000 in both modes; gated pupil planes ≥ 0.9998 replayed, ≥ 0.96 handed off.</a:t>
+              <a:t>•  The trade the cured core revealed: the starlight the vortex rejects piles just outside the geometric pupil edge, so contrast rises steeply as the stop opens toward it — a genuine depth-for-throughput dial where each fixed design is a single point. Charge 4 runs about 4× deeper than charge 6 at every stop (the smaller pixel-averaged core).</a:t>
             </a:r>
           </a:p>
           <a:p>
@@ -7903,7 +8233,7 @@
                 </a:solidFill>
                 <a:latin typeface="Arial"/>
               </a:rPr>
-              <a:t>•  Rule 1, replaying a focus: start the PROPER propagation from the exported converging-sphere plane, not from the mirror before it. The focal-plane pixel size is set by the sphere's radius; starting at the mirror gives pixels 4.5× the wrong size, and nothing overlays.</a:t>
+              <a:t>•  Readings from the curve: at the apodized-pupil Lyot's operating point, charge 4 with a 0.60 stop is deeper (8.8×10⁻¹¹ vs 2.1×10⁻¹⁰) at more throughput (36% vs 27%) — with no apodizer to fabricate. At the band-limited mask's 36% it is 300× deeper; at 81% throughput it holds 8.0×10⁻⁹, thirty times below the hard occulter's contrast at three times its throughput.</a:t>
             </a:r>
           </a:p>
           <a:p>
@@ -7919,14 +8249,14 @@
                 </a:solidFill>
                 <a:latin typeface="Arial"/>
               </a:rPr>
-              <a:t>•  Rule 2, comparing between mirrors: compare intensities, not phase maps. The two codes measure phase from different baselines (this model from a flat plane, PROPER from its internal reference beam), so identical beams still show mismatched phase. Simplest: start each PROPER stage from the exported field at that plane — that agrees by construction.</a:t>
+              <a:t>•  The steep rise past 0.90 is the leak ring arriving inside the stop (flux inside grows 0.1% → 1%); the useful range of the dial is 0.50–0.90.</a:t>
             </a:r>
           </a:p>
         </p:txBody>
       </p:sp>
       <p:pic>
         <p:nvPicPr>
-          <p:cNvPr id="5" name="Picture 4" descr="proper_ctb_check_collapsed.png"/>
+          <p:cNvPr id="5" name="Picture 4" descr="ctb_vortex_lyot_sweep.png"/>
           <p:cNvPicPr>
             <a:picLocks noChangeAspect="1"/>
           </p:cNvPicPr>
@@ -7940,8 +8270,8 @@
         </p:blipFill>
         <p:spPr>
           <a:xfrm>
-            <a:off x="6733864" y="1298448"/>
-            <a:ext cx="4728830" cy="2275332"/>
+            <a:off x="7112465" y="1298448"/>
+            <a:ext cx="3971629" cy="2760472"/>
           </a:xfrm>
           <a:prstGeom prst="rect">
             <a:avLst/>
@@ -7956,8 +8286,8 @@
         </p:nvSpPr>
         <p:spPr>
           <a:xfrm>
-            <a:off x="6400800" y="3592068"/>
-            <a:ext cx="5394960" cy="559307"/>
+            <a:off x="6400800" y="4077208"/>
+            <a:ext cx="5394960" cy="394208"/>
           </a:xfrm>
           <a:prstGeom prst="rect">
             <a:avLst/>
@@ -7982,46 +8312,7 @@
                 </a:solidFill>
                 <a:latin typeface="Arial"/>
               </a:rPr>
-              <a:t>Station-by-station intensity correlation of the external PROPER replay against the exported fields (hand-off mode): focus planes at 1.0, gated pupils above 0.96; grey bars are ungated mid-beam planes.</a:t>
-            </a:r>
-          </a:p>
-        </p:txBody>
-      </p:sp>
-      <p:sp>
-        <p:nvSpPr>
-          <p:cNvPr id="7" name="TextBox 6"/>
-          <p:cNvSpPr txBox="1"/>
-          <p:nvPr/>
-        </p:nvSpPr>
-        <p:spPr>
-          <a:xfrm>
-            <a:off x="6400800" y="4187952"/>
-            <a:ext cx="5394960" cy="274320"/>
-          </a:xfrm>
-          <a:prstGeom prst="rect">
-            <a:avLst/>
-          </a:prstGeom>
-          <a:noFill/>
-        </p:spPr>
-        <p:txBody>
-          <a:bodyPr wrap="square">
-            <a:spAutoFit/>
-          </a:bodyPr>
-          <a:lstStyle/>
-          <a:p>
-            <a:pPr>
-              <a:spcAft>
-                <a:spcPts val="600"/>
-              </a:spcAft>
-            </a:pPr>
-            <a:r>
-              <a:rPr sz="1050" b="0">
-                <a:solidFill>
-                  <a:srgbClr val="6E6E6E"/>
-                </a:solidFill>
-                <a:latin typeface="Arial"/>
-              </a:rPr>
-              <a:t>Export ≈320 MB, kept out of git: the committed truth is an 87 KB fingerprint plus a 3 MB downsampled preview, with one-command regeneration. Single wavelength; the exported OPD is wrapped (the complex field is the primary carrier). Per-wavelength export composes with the bandpass machinery when needed.</a:t>
+              <a:t>Dark-zone mean contrast against throughput: the swept vortex (point labels = Lyot fraction) against the three fixed designs from the head-to-head.</a:t>
             </a:r>
           </a:p>
         </p:txBody>
@@ -8078,7 +8369,7 @@
                 </a:solidFill>
                 <a:latin typeface="Arial"/>
               </a:rPr>
-              <a:t>7 — External hand-off: a pure-PROPER run</a:t>
+              <a:t>7 — Phase-factor export</a:t>
             </a:r>
           </a:p>
           <a:p>
@@ -8094,7 +8385,7 @@
                 </a:solidFill>
                 <a:latin typeface="Arial"/>
               </a:rPr>
-              <a:t>From the exported data alone, PROPER reproduces the bare image exactly and forms the same dark zone</a:t>
+              <a:t>External PROPER models can consume this model's planes, and check theirs against ours station by station</a:t>
             </a:r>
           </a:p>
         </p:txBody>
@@ -8177,7 +8468,7 @@
                 </a:solidFill>
                 <a:latin typeface="Arial"/>
               </a:rPr>
-              <a:t>•  The package is three files: the exported model (fields, legs, spheres, per-plane screens, mask arrays, all conventions stamped inside), a per-plane check script, and a run script that reads only the export plus PROPER — no macos anywhere. It asserts the orientation probe before trusting any comparison.</a:t>
+              <a:t>•  One self-describing file carries the full 44-element model: 18 stations (complex field, amplitude, OPD, grid pitch, all in metres), the 17 propagation legs, the 4 reference spheres, and 18 per-plane phase screens — with the sign, orientation, and centering conventions stamped inside. The orientation is measured, not asserted: a +X pupil phase ramp lands the image peak where the file says it will.</a:t>
             </a:r>
           </a:p>
           <a:p>
@@ -8193,7 +8484,7 @@
                 </a:solidFill>
                 <a:latin typeface="Arial"/>
               </a:rPr>
-              <a:t>•  A finding that shapes any external reconstruction: one single continuous PROPER beam cannot reproduce this model (focal pitch ratio 0.71, correlation 0.005). The model samples every intermediate focus at the system exit-pupil Fraunhofer pitch — set by the exit-pupil sphere radii, not by each parabola's own focal length — and one grid cannot carry both the pupil pitch and that focal pitch across a focus-to-focus relay. The shipped form is one pure-PROPER script seeded from the exported fields.</a:t>
+              <a:t>•  A companion PROPER run script reads only the exported file — no macos — and replays the model two ways: every leg propagated, or handing off at the exported fields. Focus stations reproduce at correlation 1.000000 in both modes; gated pupil planes ≥ 0.9998 replayed, ≥ 0.96 handed off.</a:t>
             </a:r>
           </a:p>
           <a:p>
@@ -8209,7 +8500,7 @@
                 </a:solidFill>
                 <a:latin typeface="Arial"/>
               </a:rPr>
-              <a:t>•  Bare image: focal pixel pitch ratio 1.0000, intensity correlation 1.000000 — the exported and PROPER images are identical.</a:t>
+              <a:t>•  Rule 1, replaying a focus: start the PROPER propagation from the exported converging-sphere plane, not from the mirror before it. The focal-plane pixel size is set by the sphere's radius; starting at the mirror gives pixels 4.5× the wrong size, and nothing overlays.</a:t>
             </a:r>
           </a:p>
           <a:p>
@@ -8225,14 +8516,14 @@
                 </a:solidFill>
                 <a:latin typeface="Arial"/>
               </a:rPr>
-              <a:t>•  Coronagraph: the PROPER cascade reaches dark-zone mean 1.4×10⁻⁸ over 3–15 λ/D. The check is one-sided by design: the idealized relay seeded at the apodizer carries the upstream aberration but omits the downstream real-mirror figure that scatters light in the full model, so it runs legitimately deeper than the shipped 2.9×10⁻⁷; the bound that matters is that it lands within 2× above the shipped value.</a:t>
+              <a:t>•  Rule 2, comparing between mirrors: compare intensities, not phase maps. The two codes measure phase from different baselines (this model from a flat plane, PROPER from its internal reference beam), so identical beams still show mismatched phase. Simplest: start each PROPER stage from the exported field at that plane — that agrees by construction.</a:t>
             </a:r>
           </a:p>
         </p:txBody>
       </p:sp>
       <p:pic>
         <p:nvPicPr>
-          <p:cNvPr id="5" name="Picture 4" descr="proper_ctb_run.png"/>
+          <p:cNvPr id="5" name="Picture 4" descr="proper_ctb_check_collapsed.png"/>
           <p:cNvPicPr>
             <a:picLocks noChangeAspect="1"/>
           </p:cNvPicPr>
@@ -8246,8 +8537,8 @@
         </p:blipFill>
         <p:spPr>
           <a:xfrm>
-            <a:off x="7628569" y="1298448"/>
-            <a:ext cx="2939420" cy="2669032"/>
+            <a:off x="6733864" y="1298448"/>
+            <a:ext cx="4728830" cy="2275332"/>
           </a:xfrm>
           <a:prstGeom prst="rect">
             <a:avLst/>
@@ -8262,8 +8553,8 @@
         </p:nvSpPr>
         <p:spPr>
           <a:xfrm>
-            <a:off x="6400800" y="3985767"/>
-            <a:ext cx="5394960" cy="394208"/>
+            <a:off x="6400800" y="3592068"/>
+            <a:ext cx="5394960" cy="559307"/>
           </a:xfrm>
           <a:prstGeom prst="rect">
             <a:avLst/>
@@ -8288,7 +8579,46 @@
                 </a:solidFill>
                 <a:latin typeface="Arial"/>
               </a:rPr>
-              <a:t>Exported (macos) beside pure-PROPER: bare images identical (correlation 1.000000); the PROPER coronagraph forms the dark zone with the shipped macos level marked.</a:t>
+              <a:t>Station-by-station intensity correlation of the external PROPER replay against the exported fields (hand-off mode): focus planes at 1.0, gated pupils above 0.96; grey bars are ungated mid-beam planes.</a:t>
+            </a:r>
+          </a:p>
+        </p:txBody>
+      </p:sp>
+      <p:sp>
+        <p:nvSpPr>
+          <p:cNvPr id="7" name="TextBox 6"/>
+          <p:cNvSpPr txBox="1"/>
+          <p:nvPr/>
+        </p:nvSpPr>
+        <p:spPr>
+          <a:xfrm>
+            <a:off x="6400800" y="4187952"/>
+            <a:ext cx="5394960" cy="274320"/>
+          </a:xfrm>
+          <a:prstGeom prst="rect">
+            <a:avLst/>
+          </a:prstGeom>
+          <a:noFill/>
+        </p:spPr>
+        <p:txBody>
+          <a:bodyPr wrap="square">
+            <a:spAutoFit/>
+          </a:bodyPr>
+          <a:lstStyle/>
+          <a:p>
+            <a:pPr>
+              <a:spcAft>
+                <a:spcPts val="600"/>
+              </a:spcAft>
+            </a:pPr>
+            <a:r>
+              <a:rPr sz="1050" b="0">
+                <a:solidFill>
+                  <a:srgbClr val="6E6E6E"/>
+                </a:solidFill>
+                <a:latin typeface="Arial"/>
+              </a:rPr>
+              <a:t>Export ≈320 MB, kept out of git: the committed truth is an 87 KB fingerprint plus a 3 MB downsampled preview, with one-command regeneration. Single wavelength; the exported OPD is wrapped (the complex field is the primary carrier). Per-wavelength export composes with the bandpass machinery when needed.</a:t>
             </a:r>
           </a:p>
         </p:txBody>
@@ -8345,7 +8675,7 @@
                 </a:solidFill>
                 <a:latin typeface="Arial"/>
               </a:rPr>
-              <a:t>8 — The deformable mirrors close the loop</a:t>
+              <a:t>8 — External hand-off: a pure-PROPER run</a:t>
             </a:r>
           </a:p>
           <a:p>
@@ -8361,7 +8691,7 @@
                 </a:solidFill>
                 <a:latin typeface="Arial"/>
               </a:rPr>
-              <a:t>Electric-field conjugation on the model itself: dark-zone mean 2.9×10⁻⁷ → 8.1×10⁻⁹ (36×) at 10 nm strokes</a:t>
+              <a:t>From the exported data alone, PROPER reproduces the bare image exactly and forms the same dark zone</a:t>
             </a:r>
           </a:p>
         </p:txBody>
@@ -8444,7 +8774,7 @@
                 </a:solidFill>
                 <a:latin typeface="Arial"/>
               </a:rPr>
-              <a:t>•  The DMs become controllable surfaces: each carries a 256-point displacement grid in its own element frame, driven by a 32×32 actuator lattice through Gaussian influence functions (12% nearest-neighbor coupling, 0.67 mm pitch = beam/32; 880 actuators of each DM sit inside the beam).</a:t>
+              <a:t>•  The package is three files: the exported model (fields, legs, spheres, per-plane screens, mask arrays, all conventions stamped inside), a per-plane check script, and a run script that reads only the export plus PROPER — no macos anywhere. It asserts the orientation probe before trusting any comparison.</a:t>
             </a:r>
           </a:p>
           <a:p>
@@ -8460,32 +8790,9 @@
                 </a:solidFill>
                 <a:latin typeface="Arial"/>
               </a:rPr>
-              <a:t>•  The control matrix is measured, not modeled: every actuator is poked 2 nm and propagated through the full masked chain — 1760 pokes, 11 minutes — so the correction solve has no model error to exploit. Each iteration re-propagates the model, scores the measured contrast, picks the regularization by that measurement, and stops itself when no step improves.</a:t>
-            </a:r>
-          </a:p>
-        </p:txBody>
-      </p:sp>
-      <p:sp>
-        <p:nvSpPr>
-          <p:cNvPr id="5" name="TextBox 4"/>
-          <p:cNvSpPr txBox="1"/>
-          <p:nvPr/>
-        </p:nvSpPr>
-        <p:spPr>
-          <a:xfrm>
-            <a:off x="6400800" y="1298448"/>
-            <a:ext cx="5394960" cy="274320"/>
-          </a:xfrm>
-          <a:prstGeom prst="rect">
-            <a:avLst/>
-          </a:prstGeom>
-          <a:noFill/>
-        </p:spPr>
-        <p:txBody>
-          <a:bodyPr wrap="square">
-            <a:spAutoFit/>
-          </a:bodyPr>
-          <a:lstStyle/>
+              <a:t>•  A finding that shapes any external reconstruction: one single continuous PROPER beam cannot reproduce this model (focal pitch ratio 0.71, correlation 0.005). The model samples every intermediate focus at the system exit-pupil Fraunhofer pitch — set by the exit-pupil sphere radii, not by each parabola's own focal length — and one grid cannot carry both the pupil pitch and that focal pitch across a focus-to-focus relay. The shipped form is one pure-PROPER script seeded from the exported fields.</a:t>
+            </a:r>
+          </a:p>
           <a:p>
             <a:pPr>
               <a:spcAft>
@@ -8499,7 +8806,7 @@
                 </a:solidFill>
                 <a:latin typeface="Arial"/>
               </a:rPr>
-              <a:t>•  Result: 2.9×10⁻⁷ → 8.1×10⁻⁹ (36×) in 19 iterations at 9.9/8.6 nm rms surface stroke. The best any linear solve of the measured matrix can reach is 4.5×10⁻⁹ at 11 nm — the loop lands within 2× of that with a matrix measured once at the flat state; re-measuring it around the corrected state is the next depth increment. Restricted to DM1 alone, the same loop stalls at 1.3×10⁻⁷ (2.3×): the pupil mirror is phase-only control, and the full annulus also needs the amplitude lever the out-of-pupil DM2 supplies.</a:t>
+              <a:t>•  Bare image: focal pixel pitch ratio 1.0000, intensity correlation 1.000000 — the exported and PROPER images are identical.</a:t>
             </a:r>
           </a:p>
           <a:p>
@@ -8515,14 +8822,14 @@
                 </a:solidFill>
                 <a:latin typeface="Arial"/>
               </a:rPr>
-              <a:t>•  Where the correction works hardest: with the 50% Lyot stop, 32 actuators steer light cleanly to about 8 λ/D on the final image scale — the inner half of the zone deepens 40×, the outer 25×, and the largest strokes ring the Lyot edge image on the mirror.</a:t>
+              <a:t>•  Coronagraph: the PROPER cascade reaches dark-zone mean 1.4×10⁻⁸ over 3–15 λ/D. The check is one-sided by design: the idealized relay seeded at the apodizer carries the upstream aberration but omits the downstream real-mirror figure that scatters light in the full model, so it runs legitimately deeper than the shipped 2.9×10⁻⁷; the bound that matters is that it lands within 2× above the shipped value.</a:t>
             </a:r>
           </a:p>
         </p:txBody>
       </p:sp>
       <p:pic>
         <p:nvPicPr>
-          <p:cNvPr id="6" name="Picture 5" descr="ctb_efc.png"/>
+          <p:cNvPr id="5" name="Picture 4" descr="proper_ctb_run.png"/>
           <p:cNvPicPr>
             <a:picLocks noChangeAspect="1"/>
           </p:cNvPicPr>
@@ -8536,8 +8843,8 @@
         </p:blipFill>
         <p:spPr>
           <a:xfrm>
-            <a:off x="2682799" y="3992879"/>
-            <a:ext cx="6826095" cy="1526032"/>
+            <a:off x="7628569" y="1298448"/>
+            <a:ext cx="2939420" cy="2669032"/>
           </a:xfrm>
           <a:prstGeom prst="rect">
             <a:avLst/>
@@ -8546,14 +8853,14 @@
       </p:pic>
       <p:sp>
         <p:nvSpPr>
-          <p:cNvPr id="7" name="TextBox 6"/>
+          <p:cNvPr id="6" name="TextBox 5"/>
           <p:cNvSpPr txBox="1"/>
           <p:nvPr/>
         </p:nvSpPr>
         <p:spPr>
           <a:xfrm>
-            <a:off x="411480" y="5537200"/>
-            <a:ext cx="11368735" cy="394208"/>
+            <a:off x="6400800" y="3985767"/>
+            <a:ext cx="5394960" cy="394208"/>
           </a:xfrm>
           <a:prstGeom prst="rect">
             <a:avLst/>
@@ -8578,46 +8885,7 @@
                 </a:solidFill>
                 <a:latin typeface="Arial"/>
               </a:rPr>
-              <a:t>Before and after at the camera; contrast versus iteration, with the DM1-only loop overlaid stalling two decades short; the stroke maps commanded on both DMs. Dashed circles mark the 3–15 λ/D zone.</a:t>
-            </a:r>
-          </a:p>
-        </p:txBody>
-      </p:sp>
-      <p:sp>
-        <p:nvSpPr>
-          <p:cNvPr id="8" name="TextBox 7"/>
-          <p:cNvSpPr txBox="1"/>
-          <p:nvPr/>
-        </p:nvSpPr>
-        <p:spPr>
-          <a:xfrm>
-            <a:off x="411480" y="5967984"/>
-            <a:ext cx="11368735" cy="274320"/>
-          </a:xfrm>
-          <a:prstGeom prst="rect">
-            <a:avLst/>
-          </a:prstGeom>
-          <a:noFill/>
-        </p:spPr>
-        <p:txBody>
-          <a:bodyPr wrap="square">
-            <a:spAutoFit/>
-          </a:bodyPr>
-          <a:lstStyle/>
-          <a:p>
-            <a:pPr>
-              <a:spcAft>
-                <a:spcPts val="600"/>
-              </a:spcAft>
-            </a:pPr>
-            <a:r>
-              <a:rPr sz="1050" b="0">
-                <a:solidFill>
-                  <a:srgbClr val="6E6E6E"/>
-                </a:solidFill>
-                <a:latin typeface="Arial"/>
-              </a:rPr>
-              <a:t>Sensing is assumed perfect — the loop reads the model's complex field directly. Estimating that field from camera images alone (pairwise probing, as a testbed must) is the next layer of realism.</a:t>
+              <a:t>Exported (macos) beside pure-PROPER: bare images identical (correlation 1.000000); the PROPER coronagraph forms the dark zone with the shipped macos level marked.</a:t>
             </a:r>
           </a:p>
         </p:txBody>

</xml_diff>

<commit_message>
deck_ctb: slide 5 marks the mask table pre-control, adds closed-loop floors
Dave's catch: the head-to-head numbers are static masks only. The
kicker, table header, and figure caption now say so explicitly, and a
compact second table under the figure carries the measured closed-loop
floors (slides 9-11, N=512): hard/0.50 mono 3.8e-9, vortex c4/0.60
mono 6.8e-15, vortex c4/0.60 10%-band unpolarized 2.0e-11 -- the
decades the DMs buy, config-honest (control chains differ from some
static rows).

Co-Authored-By: Claude Fable 5 <noreply@anthropic.com>
</commit_message>
<xml_diff>
--- a/mmacos/templates/30_instruments/bench_ctb/deck_ctb.pptx
+++ b/mmacos/templates/30_instruments/bench_ctb/deck_ctb.pptx
@@ -8182,7 +8182,7 @@
                 </a:solidFill>
                 <a:latin typeface="Arial"/>
               </a:rPr>
-              <a:t>The apodized-pupil Lyot design is deepest; the pixel-averaged vortex is second, at three times its throughput</a:t>
+              <a:t>Static masks, before any DM control: the apodized-pupil Lyot is deepest; the pixel-averaged vortex second, at three times its throughput</a:t>
             </a:r>
           </a:p>
         </p:txBody>
@@ -8296,7 +8296,7 @@
         </p:nvGraphicFramePr>
         <p:xfrm>
           <a:off x="411480" y="3398519"/>
-          <a:ext cx="5806438" cy="1960245"/>
+          <a:ext cx="5806437" cy="1960245"/>
         </p:xfrm>
         <a:graphic>
           <a:graphicData uri="http://schemas.openxmlformats.org/drawingml/2006/table">
@@ -8305,9 +8305,9 @@
                 <a:tableStyleId>{5C22544A-7EE6-4342-B048-85BDC9FD1C3A}</a:tableStyleId>
               </a:tblPr>
               <a:tblGrid>
-                <a:gridCol w="3177108"/>
-                <a:gridCol w="1533776"/>
-                <a:gridCol w="1095554"/>
+                <a:gridCol w="2806445"/>
+                <a:gridCol w="2032253"/>
+                <a:gridCol w="967739"/>
               </a:tblGrid>
               <a:tr h="280035">
                 <a:tc>
@@ -8344,7 +8344,7 @@
                           </a:solidFill>
                           <a:latin typeface="Arial"/>
                         </a:rPr>
-                        <a:t>dark-zone mean</a:t>
+                        <a:t>static dark-zone mean</a:t>
                       </a:r>
                     </a:p>
                   </a:txBody>
@@ -8844,8 +8844,8 @@
         </p:blipFill>
         <p:spPr>
           <a:xfrm>
-            <a:off x="6720188" y="1298448"/>
-            <a:ext cx="4756183" cy="2549652"/>
+            <a:off x="7061337" y="1298448"/>
+            <a:ext cx="4073885" cy="2183892"/>
           </a:xfrm>
           <a:prstGeom prst="rect">
             <a:avLst/>
@@ -8860,7 +8860,7 @@
         </p:nvSpPr>
         <p:spPr>
           <a:xfrm>
-            <a:off x="6400800" y="3866387"/>
+            <a:off x="6400800" y="3500628"/>
             <a:ext cx="5394960" cy="559307"/>
           </a:xfrm>
           <a:prstGeom prst="rect">
@@ -8886,7 +8886,7 @@
                 </a:solidFill>
                 <a:latin typeface="Arial"/>
               </a:rPr>
-              <a:t>Contrast against throughput for all six families — lower-right is better; the apodized-pupil Lyot deepest, the pixel-averaged vortex second at three times its throughput.</a:t>
+              <a:t>Contrast against throughput for all six families, STATIC — lower-right is better; the apodized-pupil Lyot deepest, the pixel-averaged vortex second at three times its throughput.</a:t>
             </a:r>
           </a:p>
         </p:txBody>
@@ -8899,7 +8899,345 @@
         </p:nvSpPr>
         <p:spPr>
           <a:xfrm>
-            <a:off x="6400800" y="4462272"/>
+            <a:off x="6400800" y="4096512"/>
+            <a:ext cx="5394960" cy="274320"/>
+          </a:xfrm>
+          <a:prstGeom prst="rect">
+            <a:avLst/>
+          </a:prstGeom>
+          <a:noFill/>
+        </p:spPr>
+        <p:txBody>
+          <a:bodyPr wrap="square">
+            <a:spAutoFit/>
+          </a:bodyPr>
+          <a:lstStyle/>
+          <a:p>
+            <a:pPr>
+              <a:spcAft>
+                <a:spcPts val="600"/>
+              </a:spcAft>
+            </a:pPr>
+            <a:r>
+              <a:rPr sz="1200" b="0">
+                <a:solidFill>
+                  <a:srgbClr val="282828"/>
+                </a:solidFill>
+                <a:latin typeface="Arial"/>
+              </a:rPr>
+              <a:t>•  Everything above is the mask alone. With the two deformable mirrors closed-loop (slides 9–11, control at N=512), the floors drop by decades:</a:t>
+            </a:r>
+          </a:p>
+        </p:txBody>
+      </p:sp>
+      <p:graphicFrame>
+        <p:nvGraphicFramePr>
+          <p:cNvPr id="10" name="Table 9"/>
+          <p:cNvGraphicFramePr>
+            <a:graphicFrameLocks noGrp="1"/>
+          </p:cNvGraphicFramePr>
+          <p:nvPr/>
+        </p:nvGraphicFramePr>
+        <p:xfrm>
+          <a:off x="6400800" y="4867656"/>
+          <a:ext cx="5394958" cy="1051560"/>
+        </p:xfrm>
+        <a:graphic>
+          <a:graphicData uri="http://schemas.openxmlformats.org/drawingml/2006/table">
+            <a:tbl>
+              <a:tblPr firstRow="1" bandRow="1">
+                <a:tableStyleId>{5C22544A-7EE6-4342-B048-85BDC9FD1C3A}</a:tableStyleId>
+              </a:tblPr>
+              <a:tblGrid>
+                <a:gridCol w="3468188"/>
+                <a:gridCol w="616566"/>
+                <a:gridCol w="1310204"/>
+              </a:tblGrid>
+              <a:tr h="262890">
+                <a:tc>
+                  <a:txBody>
+                    <a:bodyPr wrap="square"/>
+                    <a:lstStyle/>
+                    <a:p>
+                      <a:r>
+                        <a:rPr sz="1000" b="1">
+                          <a:solidFill>
+                            <a:srgbClr val="FFFFFF"/>
+                          </a:solidFill>
+                          <a:latin typeface="Arial"/>
+                        </a:rPr>
+                        <a:t>controlled chain</a:t>
+                      </a:r>
+                    </a:p>
+                  </a:txBody>
+                  <a:tcPr marL="54864" marR="54864" marT="18288" marB="18288">
+                    <a:solidFill>
+                      <a:srgbClr val="1F4E79"/>
+                    </a:solidFill>
+                  </a:tcPr>
+                </a:tc>
+                <a:tc>
+                  <a:txBody>
+                    <a:bodyPr wrap="square"/>
+                    <a:lstStyle/>
+                    <a:p>
+                      <a:r>
+                        <a:rPr sz="1000" b="1">
+                          <a:solidFill>
+                            <a:srgbClr val="FFFFFF"/>
+                          </a:solidFill>
+                          <a:latin typeface="Arial"/>
+                        </a:rPr>
+                        <a:t>static</a:t>
+                      </a:r>
+                    </a:p>
+                  </a:txBody>
+                  <a:tcPr marL="54864" marR="54864" marT="18288" marB="18288">
+                    <a:solidFill>
+                      <a:srgbClr val="1F4E79"/>
+                    </a:solidFill>
+                  </a:tcPr>
+                </a:tc>
+                <a:tc>
+                  <a:txBody>
+                    <a:bodyPr wrap="square"/>
+                    <a:lstStyle/>
+                    <a:p>
+                      <a:r>
+                        <a:rPr sz="1000" b="1">
+                          <a:solidFill>
+                            <a:srgbClr val="FFFFFF"/>
+                          </a:solidFill>
+                          <a:latin typeface="Arial"/>
+                        </a:rPr>
+                        <a:t>closed-loop floor</a:t>
+                      </a:r>
+                    </a:p>
+                  </a:txBody>
+                  <a:tcPr marL="54864" marR="54864" marT="18288" marB="18288">
+                    <a:solidFill>
+                      <a:srgbClr val="1F4E79"/>
+                    </a:solidFill>
+                  </a:tcPr>
+                </a:tc>
+              </a:tr>
+              <a:tr h="262890">
+                <a:tc>
+                  <a:txBody>
+                    <a:bodyPr wrap="square"/>
+                    <a:lstStyle/>
+                    <a:p>
+                      <a:r>
+                        <a:rPr sz="1000" b="0">
+                          <a:solidFill>
+                            <a:srgbClr val="282828"/>
+                          </a:solidFill>
+                          <a:latin typeface="Arial"/>
+                        </a:rPr>
+                        <a:t>hard occulter, Lyot 0.50 (mono)</a:t>
+                      </a:r>
+                    </a:p>
+                  </a:txBody>
+                  <a:tcPr marL="54864" marR="54864" marT="18288" marB="18288">
+                    <a:solidFill>
+                      <a:srgbClr val="FFFFFF"/>
+                    </a:solidFill>
+                  </a:tcPr>
+                </a:tc>
+                <a:tc>
+                  <a:txBody>
+                    <a:bodyPr wrap="square"/>
+                    <a:lstStyle/>
+                    <a:p>
+                      <a:r>
+                        <a:rPr sz="1000" b="0">
+                          <a:solidFill>
+                            <a:srgbClr val="282828"/>
+                          </a:solidFill>
+                          <a:latin typeface="Arial"/>
+                        </a:rPr>
+                        <a:t>2.9×10⁻⁷</a:t>
+                      </a:r>
+                    </a:p>
+                  </a:txBody>
+                  <a:tcPr marL="54864" marR="54864" marT="18288" marB="18288">
+                    <a:solidFill>
+                      <a:srgbClr val="FFFFFF"/>
+                    </a:solidFill>
+                  </a:tcPr>
+                </a:tc>
+                <a:tc>
+                  <a:txBody>
+                    <a:bodyPr wrap="square"/>
+                    <a:lstStyle/>
+                    <a:p>
+                      <a:r>
+                        <a:rPr sz="1000" b="0">
+                          <a:solidFill>
+                            <a:srgbClr val="282828"/>
+                          </a:solidFill>
+                          <a:latin typeface="Arial"/>
+                        </a:rPr>
+                        <a:t>3.8×10⁻⁹</a:t>
+                      </a:r>
+                    </a:p>
+                  </a:txBody>
+                  <a:tcPr marL="54864" marR="54864" marT="18288" marB="18288">
+                    <a:solidFill>
+                      <a:srgbClr val="FFFFFF"/>
+                    </a:solidFill>
+                  </a:tcPr>
+                </a:tc>
+              </a:tr>
+              <a:tr h="262890">
+                <a:tc>
+                  <a:txBody>
+                    <a:bodyPr wrap="square"/>
+                    <a:lstStyle/>
+                    <a:p>
+                      <a:r>
+                        <a:rPr sz="1000" b="0">
+                          <a:solidFill>
+                            <a:srgbClr val="282828"/>
+                          </a:solidFill>
+                          <a:latin typeface="Arial"/>
+                        </a:rPr>
+                        <a:t>vortex charge 4, Lyot 0.60 (mono)</a:t>
+                      </a:r>
+                    </a:p>
+                  </a:txBody>
+                  <a:tcPr marL="54864" marR="54864" marT="18288" marB="18288">
+                    <a:solidFill>
+                      <a:srgbClr val="ECF1F6"/>
+                    </a:solidFill>
+                  </a:tcPr>
+                </a:tc>
+                <a:tc>
+                  <a:txBody>
+                    <a:bodyPr wrap="square"/>
+                    <a:lstStyle/>
+                    <a:p>
+                      <a:r>
+                        <a:rPr sz="1000" b="0">
+                          <a:solidFill>
+                            <a:srgbClr val="282828"/>
+                          </a:solidFill>
+                          <a:latin typeface="Arial"/>
+                        </a:rPr>
+                        <a:t>1.7×10⁻⁸</a:t>
+                      </a:r>
+                    </a:p>
+                  </a:txBody>
+                  <a:tcPr marL="54864" marR="54864" marT="18288" marB="18288">
+                    <a:solidFill>
+                      <a:srgbClr val="ECF1F6"/>
+                    </a:solidFill>
+                  </a:tcPr>
+                </a:tc>
+                <a:tc>
+                  <a:txBody>
+                    <a:bodyPr wrap="square"/>
+                    <a:lstStyle/>
+                    <a:p>
+                      <a:r>
+                        <a:rPr sz="1000" b="0">
+                          <a:solidFill>
+                            <a:srgbClr val="282828"/>
+                          </a:solidFill>
+                          <a:latin typeface="Arial"/>
+                        </a:rPr>
+                        <a:t>6.8×10⁻¹⁵</a:t>
+                      </a:r>
+                    </a:p>
+                  </a:txBody>
+                  <a:tcPr marL="54864" marR="54864" marT="18288" marB="18288">
+                    <a:solidFill>
+                      <a:srgbClr val="ECF1F6"/>
+                    </a:solidFill>
+                  </a:tcPr>
+                </a:tc>
+              </a:tr>
+              <a:tr h="262890">
+                <a:tc>
+                  <a:txBody>
+                    <a:bodyPr wrap="square"/>
+                    <a:lstStyle/>
+                    <a:p>
+                      <a:r>
+                        <a:rPr sz="1000" b="0">
+                          <a:solidFill>
+                            <a:srgbClr val="282828"/>
+                          </a:solidFill>
+                          <a:latin typeface="Arial"/>
+                        </a:rPr>
+                        <a:t>vortex charge 4, Lyot 0.60 (10% band, unpol.)</a:t>
+                      </a:r>
+                    </a:p>
+                  </a:txBody>
+                  <a:tcPr marL="54864" marR="54864" marT="18288" marB="18288">
+                    <a:solidFill>
+                      <a:srgbClr val="FFFFFF"/>
+                    </a:solidFill>
+                  </a:tcPr>
+                </a:tc>
+                <a:tc>
+                  <a:txBody>
+                    <a:bodyPr wrap="square"/>
+                    <a:lstStyle/>
+                    <a:p>
+                      <a:r>
+                        <a:rPr sz="1000" b="0">
+                          <a:solidFill>
+                            <a:srgbClr val="282828"/>
+                          </a:solidFill>
+                          <a:latin typeface="Arial"/>
+                        </a:rPr>
+                        <a:t>2.2×10⁻⁸</a:t>
+                      </a:r>
+                    </a:p>
+                  </a:txBody>
+                  <a:tcPr marL="54864" marR="54864" marT="18288" marB="18288">
+                    <a:solidFill>
+                      <a:srgbClr val="FFFFFF"/>
+                    </a:solidFill>
+                  </a:tcPr>
+                </a:tc>
+                <a:tc>
+                  <a:txBody>
+                    <a:bodyPr wrap="square"/>
+                    <a:lstStyle/>
+                    <a:p>
+                      <a:r>
+                        <a:rPr sz="1000" b="0">
+                          <a:solidFill>
+                            <a:srgbClr val="282828"/>
+                          </a:solidFill>
+                          <a:latin typeface="Arial"/>
+                        </a:rPr>
+                        <a:t>2.0×10⁻¹¹</a:t>
+                      </a:r>
+                    </a:p>
+                  </a:txBody>
+                  <a:tcPr marL="54864" marR="54864" marT="18288" marB="18288">
+                    <a:solidFill>
+                      <a:srgbClr val="FFFFFF"/>
+                    </a:solidFill>
+                  </a:tcPr>
+                </a:tc>
+              </a:tr>
+            </a:tbl>
+          </a:graphicData>
+        </a:graphic>
+      </p:graphicFrame>
+      <p:sp>
+        <p:nvSpPr>
+          <p:cNvPr id="11" name="TextBox 10"/>
+          <p:cNvSpPr txBox="1"/>
+          <p:nvPr/>
+        </p:nvSpPr>
+        <p:spPr>
+          <a:xfrm>
+            <a:off x="6400800" y="6065520"/>
             <a:ext cx="5394960" cy="274320"/>
           </a:xfrm>
           <a:prstGeom prst="rect">

</xml_diff>